<commit_message>
Fix 7 slide layout issues
- Slide 1: '30 分钟技术分享' -> '技术分享'
- Slide 4: shrink text, add image placeholders for waveform/spectrogram
- Slide 17: fix table row heights to avoid waveform overlap
- Slide 18: fix table alignment, remove empty column, avoid overlap
- Slide 19: move Affine Coupling Layer section up
- Slide 21: remove empty flowBox at top
- Move '完整链路' from slide 22 to slide 16

Co-Authored-By: Claude Opus 4.8 <noreply@anthropic.com>
</commit_message>
<xml_diff>
--- a/TTS_Talk_SignalFlow.pptx
+++ b/TTS_Talk_SignalFlow.pptx
@@ -3228,7 +3228,7 @@
                 <a:ea typeface="Calibri" pitchFamily="34" charset="-122"/>
                 <a:cs typeface="Calibri" pitchFamily="34" charset="-120"/>
               </a:rPr>
-              <a:t>30 分钟技术分享</a:t>
+              <a:t>技术分享</a:t>
             </a:r>
             <a:endParaRPr lang="en-US" sz="1600" dirty="0"/>
           </a:p>
@@ -11016,6 +11016,45 @@
         </p:nvSpPr>
         <p:spPr>
           <a:xfrm>
+            <a:off x="457200" y="1051560"/>
+            <a:ext cx="8229600" cy="182880"/>
+          </a:xfrm>
+          <a:prstGeom prst="rect">
+            <a:avLst/>
+          </a:prstGeom>
+          <a:noFill/>
+          <a:ln/>
+        </p:spPr>
+        <p:txBody>
+          <a:bodyPr wrap="square" lIns="0" tIns="0" rIns="0" bIns="0" rtlCol="0" anchor="ctr"/>
+          <a:lstStyle/>
+          <a:p>
+            <a:pPr indent="0" marL="0">
+              <a:buNone/>
+            </a:pPr>
+            <a:r>
+              <a:rPr lang="en-US" sz="1100" i="1" dirty="0">
+                <a:solidFill>
+                  <a:srgbClr val="9CA3A8"/>
+                </a:solidFill>
+                <a:latin typeface="Calibri" pitchFamily="34" charset="0"/>
+                <a:ea typeface="Calibri" pitchFamily="34" charset="-122"/>
+                <a:cs typeface="Calibri" pitchFamily="34" charset="-120"/>
+              </a:rPr>
+              <a:t>完整链路：大家好 → 音素 → TextEncoder → z → HiFi-GAN → 波形</a:t>
+            </a:r>
+            <a:endParaRPr lang="en-US" sz="1100" dirty="0"/>
+          </a:p>
+        </p:txBody>
+      </p:sp>
+      <p:sp>
+        <p:nvSpPr>
+          <p:cNvPr id="21" name="Text 19"/>
+          <p:cNvSpPr/>
+          <p:nvPr/>
+        </p:nvSpPr>
+        <p:spPr>
+          <a:xfrm>
             <a:off x="274320" y="1280160"/>
             <a:ext cx="4297680" cy="256032"/>
           </a:xfrm>
@@ -11049,7 +11088,7 @@
       </p:sp>
       <p:sp>
         <p:nvSpPr>
-          <p:cNvPr id="21" name="Shape 19"/>
+          <p:cNvPr id="22" name="Shape 20"/>
           <p:cNvSpPr/>
           <p:nvPr/>
         </p:nvSpPr>
@@ -11076,7 +11115,7 @@
       </p:sp>
       <p:sp>
         <p:nvSpPr>
-          <p:cNvPr id="22" name="Text 20"/>
+          <p:cNvPr id="23" name="Text 21"/>
           <p:cNvSpPr/>
           <p:nvPr/>
         </p:nvSpPr>
@@ -11115,7 +11154,7 @@
       </p:sp>
       <p:sp>
         <p:nvSpPr>
-          <p:cNvPr id="23" name="Shape 21"/>
+          <p:cNvPr id="24" name="Shape 22"/>
           <p:cNvSpPr/>
           <p:nvPr/>
         </p:nvSpPr>
@@ -11142,7 +11181,7 @@
       </p:sp>
       <p:sp>
         <p:nvSpPr>
-          <p:cNvPr id="24" name="Text 22"/>
+          <p:cNvPr id="25" name="Text 23"/>
           <p:cNvSpPr/>
           <p:nvPr/>
         </p:nvSpPr>
@@ -11181,7 +11220,7 @@
       </p:sp>
       <p:sp>
         <p:nvSpPr>
-          <p:cNvPr id="25" name="Text 23"/>
+          <p:cNvPr id="26" name="Text 24"/>
           <p:cNvSpPr/>
           <p:nvPr/>
         </p:nvSpPr>
@@ -11220,7 +11259,7 @@
       </p:sp>
       <p:sp>
         <p:nvSpPr>
-          <p:cNvPr id="26" name="Text 24"/>
+          <p:cNvPr id="27" name="Text 25"/>
           <p:cNvSpPr/>
           <p:nvPr/>
         </p:nvSpPr>
@@ -11259,7 +11298,7 @@
       </p:sp>
       <p:sp>
         <p:nvSpPr>
-          <p:cNvPr id="27" name="Shape 25"/>
+          <p:cNvPr id="28" name="Shape 26"/>
           <p:cNvSpPr/>
           <p:nvPr/>
         </p:nvSpPr>
@@ -11286,7 +11325,7 @@
       </p:sp>
       <p:sp>
         <p:nvSpPr>
-          <p:cNvPr id="28" name="Text 26"/>
+          <p:cNvPr id="29" name="Text 27"/>
           <p:cNvSpPr/>
           <p:nvPr/>
         </p:nvSpPr>
@@ -11325,7 +11364,7 @@
       </p:sp>
       <p:sp>
         <p:nvSpPr>
-          <p:cNvPr id="29" name="Shape 27"/>
+          <p:cNvPr id="30" name="Shape 28"/>
           <p:cNvSpPr/>
           <p:nvPr/>
         </p:nvSpPr>
@@ -11352,7 +11391,7 @@
       </p:sp>
       <p:sp>
         <p:nvSpPr>
-          <p:cNvPr id="30" name="Text 28"/>
+          <p:cNvPr id="31" name="Text 29"/>
           <p:cNvSpPr/>
           <p:nvPr/>
         </p:nvSpPr>
@@ -11391,7 +11430,7 @@
       </p:sp>
       <p:sp>
         <p:nvSpPr>
-          <p:cNvPr id="31" name="Text 29"/>
+          <p:cNvPr id="32" name="Text 30"/>
           <p:cNvSpPr/>
           <p:nvPr/>
         </p:nvSpPr>
@@ -11430,7 +11469,7 @@
       </p:sp>
       <p:sp>
         <p:nvSpPr>
-          <p:cNvPr id="32" name="Text 30"/>
+          <p:cNvPr id="33" name="Text 31"/>
           <p:cNvSpPr/>
           <p:nvPr/>
         </p:nvSpPr>
@@ -11469,7 +11508,7 @@
       </p:sp>
       <p:sp>
         <p:nvSpPr>
-          <p:cNvPr id="33" name="Shape 31"/>
+          <p:cNvPr id="34" name="Shape 32"/>
           <p:cNvSpPr/>
           <p:nvPr/>
         </p:nvSpPr>
@@ -11496,7 +11535,7 @@
       </p:sp>
       <p:sp>
         <p:nvSpPr>
-          <p:cNvPr id="34" name="Text 32"/>
+          <p:cNvPr id="35" name="Text 33"/>
           <p:cNvSpPr/>
           <p:nvPr/>
         </p:nvSpPr>
@@ -11535,7 +11574,7 @@
       </p:sp>
       <p:sp>
         <p:nvSpPr>
-          <p:cNvPr id="35" name="Shape 33"/>
+          <p:cNvPr id="36" name="Shape 34"/>
           <p:cNvSpPr/>
           <p:nvPr/>
         </p:nvSpPr>
@@ -11562,7 +11601,7 @@
       </p:sp>
       <p:sp>
         <p:nvSpPr>
-          <p:cNvPr id="36" name="Text 34"/>
+          <p:cNvPr id="37" name="Text 35"/>
           <p:cNvSpPr/>
           <p:nvPr/>
         </p:nvSpPr>
@@ -11601,7 +11640,7 @@
       </p:sp>
       <p:sp>
         <p:nvSpPr>
-          <p:cNvPr id="37" name="Text 35"/>
+          <p:cNvPr id="38" name="Text 36"/>
           <p:cNvSpPr/>
           <p:nvPr/>
         </p:nvSpPr>
@@ -11640,7 +11679,7 @@
       </p:sp>
       <p:sp>
         <p:nvSpPr>
-          <p:cNvPr id="38" name="Text 36"/>
+          <p:cNvPr id="39" name="Text 37"/>
           <p:cNvSpPr/>
           <p:nvPr/>
         </p:nvSpPr>
@@ -11679,7 +11718,7 @@
       </p:sp>
       <p:sp>
         <p:nvSpPr>
-          <p:cNvPr id="39" name="Shape 37"/>
+          <p:cNvPr id="40" name="Shape 38"/>
           <p:cNvSpPr/>
           <p:nvPr/>
         </p:nvSpPr>
@@ -11706,7 +11745,7 @@
       </p:sp>
       <p:sp>
         <p:nvSpPr>
-          <p:cNvPr id="40" name="Text 38"/>
+          <p:cNvPr id="41" name="Text 39"/>
           <p:cNvSpPr/>
           <p:nvPr/>
         </p:nvSpPr>
@@ -11745,7 +11784,7 @@
       </p:sp>
       <p:sp>
         <p:nvSpPr>
-          <p:cNvPr id="41" name="Shape 39"/>
+          <p:cNvPr id="42" name="Shape 40"/>
           <p:cNvSpPr/>
           <p:nvPr/>
         </p:nvSpPr>
@@ -11772,7 +11811,7 @@
       </p:sp>
       <p:sp>
         <p:nvSpPr>
-          <p:cNvPr id="42" name="Text 40"/>
+          <p:cNvPr id="43" name="Text 41"/>
           <p:cNvSpPr/>
           <p:nvPr/>
         </p:nvSpPr>
@@ -11811,7 +11850,7 @@
       </p:sp>
       <p:sp>
         <p:nvSpPr>
-          <p:cNvPr id="43" name="Shape 41"/>
+          <p:cNvPr id="44" name="Shape 42"/>
           <p:cNvSpPr/>
           <p:nvPr/>
         </p:nvSpPr>
@@ -11831,7 +11870,7 @@
       </p:sp>
       <p:sp>
         <p:nvSpPr>
-          <p:cNvPr id="44" name="Text 42"/>
+          <p:cNvPr id="45" name="Text 43"/>
           <p:cNvSpPr/>
           <p:nvPr/>
         </p:nvSpPr>
@@ -11870,7 +11909,7 @@
       </p:sp>
       <p:sp>
         <p:nvSpPr>
-          <p:cNvPr id="45" name="Shape 43"/>
+          <p:cNvPr id="46" name="Shape 44"/>
           <p:cNvSpPr/>
           <p:nvPr/>
         </p:nvSpPr>
@@ -11897,7 +11936,7 @@
       </p:sp>
       <p:sp>
         <p:nvSpPr>
-          <p:cNvPr id="46" name="Text 44"/>
+          <p:cNvPr id="47" name="Text 45"/>
           <p:cNvSpPr/>
           <p:nvPr/>
         </p:nvSpPr>
@@ -11936,7 +11975,7 @@
       </p:sp>
       <p:sp>
         <p:nvSpPr>
-          <p:cNvPr id="47" name="Text 45"/>
+          <p:cNvPr id="48" name="Text 46"/>
           <p:cNvSpPr/>
           <p:nvPr/>
         </p:nvSpPr>
@@ -11975,7 +12014,7 @@
       </p:sp>
       <p:sp>
         <p:nvSpPr>
-          <p:cNvPr id="48" name="Shape 46"/>
+          <p:cNvPr id="49" name="Shape 47"/>
           <p:cNvSpPr/>
           <p:nvPr/>
         </p:nvSpPr>
@@ -12002,7 +12041,7 @@
       </p:sp>
       <p:sp>
         <p:nvSpPr>
-          <p:cNvPr id="49" name="Text 47"/>
+          <p:cNvPr id="50" name="Text 48"/>
           <p:cNvSpPr/>
           <p:nvPr/>
         </p:nvSpPr>
@@ -12041,7 +12080,7 @@
       </p:sp>
       <p:sp>
         <p:nvSpPr>
-          <p:cNvPr id="50" name="Text 48"/>
+          <p:cNvPr id="51" name="Text 49"/>
           <p:cNvSpPr/>
           <p:nvPr/>
         </p:nvSpPr>
@@ -12080,7 +12119,7 @@
       </p:sp>
       <p:sp>
         <p:nvSpPr>
-          <p:cNvPr id="51" name="Shape 49"/>
+          <p:cNvPr id="52" name="Shape 50"/>
           <p:cNvSpPr/>
           <p:nvPr/>
         </p:nvSpPr>
@@ -12107,7 +12146,7 @@
       </p:sp>
       <p:sp>
         <p:nvSpPr>
-          <p:cNvPr id="52" name="Text 50"/>
+          <p:cNvPr id="53" name="Text 51"/>
           <p:cNvSpPr/>
           <p:nvPr/>
         </p:nvSpPr>
@@ -12146,7 +12185,7 @@
       </p:sp>
       <p:sp>
         <p:nvSpPr>
-          <p:cNvPr id="53" name="Text 51"/>
+          <p:cNvPr id="54" name="Text 52"/>
           <p:cNvSpPr/>
           <p:nvPr/>
         </p:nvSpPr>
@@ -12185,7 +12224,7 @@
       </p:sp>
       <p:sp>
         <p:nvSpPr>
-          <p:cNvPr id="54" name="Shape 52"/>
+          <p:cNvPr id="55" name="Shape 53"/>
           <p:cNvSpPr/>
           <p:nvPr/>
         </p:nvSpPr>
@@ -12212,7 +12251,7 @@
       </p:sp>
       <p:sp>
         <p:nvSpPr>
-          <p:cNvPr id="55" name="Text 53"/>
+          <p:cNvPr id="56" name="Text 54"/>
           <p:cNvSpPr/>
           <p:nvPr/>
         </p:nvSpPr>
@@ -12251,7 +12290,7 @@
       </p:sp>
       <p:sp>
         <p:nvSpPr>
-          <p:cNvPr id="56" name="Text 54"/>
+          <p:cNvPr id="57" name="Text 55"/>
           <p:cNvSpPr/>
           <p:nvPr/>
         </p:nvSpPr>
@@ -12290,7 +12329,7 @@
       </p:sp>
       <p:sp>
         <p:nvSpPr>
-          <p:cNvPr id="57" name="Shape 55"/>
+          <p:cNvPr id="58" name="Shape 56"/>
           <p:cNvSpPr/>
           <p:nvPr/>
         </p:nvSpPr>
@@ -12317,7 +12356,7 @@
       </p:sp>
       <p:sp>
         <p:nvSpPr>
-          <p:cNvPr id="58" name="Text 56"/>
+          <p:cNvPr id="59" name="Text 57"/>
           <p:cNvSpPr/>
           <p:nvPr/>
         </p:nvSpPr>
@@ -12356,7 +12395,7 @@
       </p:sp>
       <p:sp>
         <p:nvSpPr>
-          <p:cNvPr id="59" name="Text 57"/>
+          <p:cNvPr id="60" name="Text 58"/>
           <p:cNvSpPr/>
           <p:nvPr/>
         </p:nvSpPr>
@@ -12395,7 +12434,7 @@
       </p:sp>
       <p:sp>
         <p:nvSpPr>
-          <p:cNvPr id="60" name="Shape 58"/>
+          <p:cNvPr id="61" name="Shape 59"/>
           <p:cNvSpPr/>
           <p:nvPr/>
         </p:nvSpPr>
@@ -12422,7 +12461,7 @@
       </p:sp>
       <p:sp>
         <p:nvSpPr>
-          <p:cNvPr id="61" name="Text 59"/>
+          <p:cNvPr id="62" name="Text 60"/>
           <p:cNvSpPr/>
           <p:nvPr/>
         </p:nvSpPr>
@@ -12461,7 +12500,7 @@
       </p:sp>
       <p:sp>
         <p:nvSpPr>
-          <p:cNvPr id="62" name="Text 60"/>
+          <p:cNvPr id="63" name="Text 61"/>
           <p:cNvSpPr/>
           <p:nvPr/>
         </p:nvSpPr>
@@ -12500,7 +12539,7 @@
       </p:sp>
       <p:sp>
         <p:nvSpPr>
-          <p:cNvPr id="63" name="Shape 61"/>
+          <p:cNvPr id="64" name="Shape 62"/>
           <p:cNvSpPr/>
           <p:nvPr/>
         </p:nvSpPr>
@@ -12527,7 +12566,7 @@
       </p:sp>
       <p:sp>
         <p:nvSpPr>
-          <p:cNvPr id="64" name="Text 62"/>
+          <p:cNvPr id="65" name="Text 63"/>
           <p:cNvSpPr/>
           <p:nvPr/>
         </p:nvSpPr>
@@ -12566,7 +12605,7 @@
       </p:sp>
       <p:sp>
         <p:nvSpPr>
-          <p:cNvPr id="65" name="Text 63"/>
+          <p:cNvPr id="66" name="Text 64"/>
           <p:cNvSpPr/>
           <p:nvPr/>
         </p:nvSpPr>
@@ -12605,7 +12644,7 @@
       </p:sp>
       <p:sp>
         <p:nvSpPr>
-          <p:cNvPr id="66" name="Shape 64"/>
+          <p:cNvPr id="67" name="Shape 65"/>
           <p:cNvSpPr/>
           <p:nvPr/>
         </p:nvSpPr>
@@ -12632,7 +12671,7 @@
       </p:sp>
       <p:sp>
         <p:nvSpPr>
-          <p:cNvPr id="67" name="Text 65"/>
+          <p:cNvPr id="68" name="Text 66"/>
           <p:cNvSpPr/>
           <p:nvPr/>
         </p:nvSpPr>
@@ -12671,7 +12710,7 @@
       </p:sp>
       <p:sp>
         <p:nvSpPr>
-          <p:cNvPr id="68" name="Text 66"/>
+          <p:cNvPr id="69" name="Text 67"/>
           <p:cNvSpPr/>
           <p:nvPr/>
         </p:nvSpPr>
@@ -12710,7 +12749,7 @@
       </p:sp>
       <p:sp>
         <p:nvSpPr>
-          <p:cNvPr id="69" name="Shape 67"/>
+          <p:cNvPr id="70" name="Shape 68"/>
           <p:cNvSpPr/>
           <p:nvPr/>
         </p:nvSpPr>
@@ -12737,7 +12776,7 @@
       </p:sp>
       <p:sp>
         <p:nvSpPr>
-          <p:cNvPr id="70" name="Text 68"/>
+          <p:cNvPr id="71" name="Text 69"/>
           <p:cNvSpPr/>
           <p:nvPr/>
         </p:nvSpPr>
@@ -12776,7 +12815,7 @@
       </p:sp>
       <p:sp>
         <p:nvSpPr>
-          <p:cNvPr id="71" name="Text 69"/>
+          <p:cNvPr id="72" name="Text 70"/>
           <p:cNvSpPr/>
           <p:nvPr/>
         </p:nvSpPr>
@@ -12815,7 +12854,7 @@
       </p:sp>
       <p:sp>
         <p:nvSpPr>
-          <p:cNvPr id="72" name="Shape 70"/>
+          <p:cNvPr id="73" name="Shape 71"/>
           <p:cNvSpPr/>
           <p:nvPr/>
         </p:nvSpPr>
@@ -12842,7 +12881,7 @@
       </p:sp>
       <p:sp>
         <p:nvSpPr>
-          <p:cNvPr id="73" name="Text 71"/>
+          <p:cNvPr id="74" name="Text 72"/>
           <p:cNvSpPr/>
           <p:nvPr/>
         </p:nvSpPr>
@@ -12881,7 +12920,7 @@
       </p:sp>
       <p:sp>
         <p:nvSpPr>
-          <p:cNvPr id="74" name="Text 72"/>
+          <p:cNvPr id="75" name="Text 73"/>
           <p:cNvSpPr/>
           <p:nvPr/>
         </p:nvSpPr>
@@ -12920,7 +12959,7 @@
       </p:sp>
       <p:sp>
         <p:nvSpPr>
-          <p:cNvPr id="75" name="Shape 73"/>
+          <p:cNvPr id="76" name="Shape 74"/>
           <p:cNvSpPr/>
           <p:nvPr/>
         </p:nvSpPr>
@@ -12947,7 +12986,7 @@
       </p:sp>
       <p:sp>
         <p:nvSpPr>
-          <p:cNvPr id="76" name="Text 74"/>
+          <p:cNvPr id="77" name="Text 75"/>
           <p:cNvSpPr/>
           <p:nvPr/>
         </p:nvSpPr>
@@ -12986,7 +13025,7 @@
       </p:sp>
       <p:sp>
         <p:nvSpPr>
-          <p:cNvPr id="77" name="Text 75"/>
+          <p:cNvPr id="78" name="Text 76"/>
           <p:cNvSpPr/>
           <p:nvPr/>
         </p:nvSpPr>
@@ -13025,7 +13064,7 @@
       </p:sp>
       <p:sp>
         <p:nvSpPr>
-          <p:cNvPr id="78" name="Shape 76"/>
+          <p:cNvPr id="79" name="Shape 77"/>
           <p:cNvSpPr/>
           <p:nvPr/>
         </p:nvSpPr>
@@ -13052,7 +13091,7 @@
       </p:sp>
       <p:sp>
         <p:nvSpPr>
-          <p:cNvPr id="79" name="Text 77"/>
+          <p:cNvPr id="80" name="Text 78"/>
           <p:cNvSpPr/>
           <p:nvPr/>
         </p:nvSpPr>
@@ -13091,7 +13130,7 @@
       </p:sp>
       <p:sp>
         <p:nvSpPr>
-          <p:cNvPr id="80" name="Text 78"/>
+          <p:cNvPr id="81" name="Text 79"/>
           <p:cNvSpPr/>
           <p:nvPr/>
         </p:nvSpPr>
@@ -15819,8 +15858,8 @@
         </p:nvSpPr>
         <p:spPr>
           <a:xfrm>
-            <a:off x="457200" y="4023360"/>
-            <a:ext cx="8229600" cy="274320"/>
+            <a:off x="457200" y="3931920"/>
+            <a:ext cx="8229600" cy="228600"/>
           </a:xfrm>
           <a:prstGeom prst="rect">
             <a:avLst/>
@@ -15865,76 +15904,18 @@
           </p:nvPr>
         </p:nvGraphicFramePr>
         <p:xfrm>
-          <a:off x="1371600" y="4206240"/>
-          <a:ext cx="6400800" cy="914400"/>
+          <a:off x="457200" y="4206240"/>
+          <a:ext cx="8229600" cy="914400"/>
         </p:xfrm>
         <a:graphic>
           <a:graphicData uri="http://schemas.openxmlformats.org/drawingml/2006/table">
             <a:tbl>
               <a:tblPr/>
               <a:tblGrid>
-                <a:gridCol w="1645920"/>
-                <a:gridCol w="3291840"/>
-                <a:gridCol w="3291840"/>
+                <a:gridCol w="4114800"/>
+                <a:gridCol w="4114800"/>
               </a:tblGrid>
-              <a:tr h="228600">
-                <a:tc>
-                  <a:txBody>
-                    <a:bodyPr/>
-                    <a:lstStyle/>
-                    <a:p>
-                      <a:pPr algn="ctr" indent="0" marL="0">
-                        <a:buNone/>
-                      </a:pPr>
-                      <a:endParaRPr lang="en-US" sz="1100" dirty="0">
-                        <a:latin typeface="Calibri" charset="0"/>
-                        <a:ea typeface="Calibri" charset="0"/>
-                        <a:cs typeface="Calibri" charset="0"/>
-                      </a:endParaRPr>
-                    </a:p>
-                  </a:txBody>
-                  <a:tcPr marL="91440" marR="91440" marT="45720" marB="45720" anchor="ctr">
-                    <a:lnL w="12700" cap="flat" cmpd="sng" algn="ctr">
-                      <a:solidFill>
-                        <a:srgbClr val="FFFFFF"/>
-                      </a:solidFill>
-                      <a:prstDash val="solid"/>
-                      <a:round/>
-                      <a:headEnd type="none" w="med" len="med"/>
-                      <a:tailEnd type="none" w="med" len="med"/>
-                    </a:lnL>
-                    <a:lnR w="12700" cap="flat" cmpd="sng" algn="ctr">
-                      <a:solidFill>
-                        <a:srgbClr val="FFFFFF"/>
-                      </a:solidFill>
-                      <a:prstDash val="solid"/>
-                      <a:round/>
-                      <a:headEnd type="none" w="med" len="med"/>
-                      <a:tailEnd type="none" w="med" len="med"/>
-                    </a:lnR>
-                    <a:lnT w="12700" cap="flat" cmpd="sng" algn="ctr">
-                      <a:solidFill>
-                        <a:srgbClr val="FFFFFF"/>
-                      </a:solidFill>
-                      <a:prstDash val="solid"/>
-                      <a:round/>
-                      <a:headEnd type="none" w="med" len="med"/>
-                      <a:tailEnd type="none" w="med" len="med"/>
-                    </a:lnT>
-                    <a:lnB w="12700" cap="flat" cmpd="sng" algn="ctr">
-                      <a:solidFill>
-                        <a:srgbClr val="FFFFFF"/>
-                      </a:solidFill>
-                      <a:prstDash val="solid"/>
-                      <a:round/>
-                      <a:headEnd type="none" w="med" len="med"/>
-                      <a:tailEnd type="none" w="med" len="med"/>
-                    </a:lnB>
-                    <a:solidFill>
-                      <a:srgbClr val="FFFFFF"/>
-                    </a:solidFill>
-                  </a:tcPr>
-                </a:tc>
+              <a:tr h="182880">
                 <a:tc>
                   <a:txBody>
                     <a:bodyPr/>
@@ -16072,75 +16053,7 @@
                   </a:tcPr>
                 </a:tc>
               </a:tr>
-              <a:tr h="182880">
-                <a:tc>
-                  <a:txBody>
-                    <a:bodyPr/>
-                    <a:lstStyle/>
-                    <a:p>
-                      <a:pPr algn="ctr" indent="0" marL="0">
-                        <a:buNone/>
-                      </a:pPr>
-                      <a:r>
-                        <a:rPr lang="en-US" sz="1100" dirty="0">
-                          <a:solidFill>
-                            <a:srgbClr val="636E72"/>
-                          </a:solidFill>
-                          <a:latin typeface="Calibri" pitchFamily="34" charset="0"/>
-                          <a:ea typeface="Calibri" pitchFamily="34" charset="-122"/>
-                          <a:cs typeface="Calibri" pitchFamily="34" charset="-120"/>
-                        </a:rPr>
-                        <a:t>时长来源</a:t>
-                      </a:r>
-                      <a:endParaRPr lang="en-US" sz="1100" dirty="0">
-                        <a:latin typeface="Calibri" charset="0"/>
-                        <a:ea typeface="Calibri" charset="0"/>
-                        <a:cs typeface="Calibri" charset="0"/>
-                      </a:endParaRPr>
-                    </a:p>
-                  </a:txBody>
-                  <a:tcPr marL="91440" marR="91440" marT="45720" marB="45720" anchor="ctr">
-                    <a:lnL w="12700" cap="flat" cmpd="sng" algn="ctr">
-                      <a:solidFill>
-                        <a:srgbClr val="FFFFFF"/>
-                      </a:solidFill>
-                      <a:prstDash val="solid"/>
-                      <a:round/>
-                      <a:headEnd type="none" w="med" len="med"/>
-                      <a:tailEnd type="none" w="med" len="med"/>
-                    </a:lnL>
-                    <a:lnR w="12700" cap="flat" cmpd="sng" algn="ctr">
-                      <a:solidFill>
-                        <a:srgbClr val="FFFFFF"/>
-                      </a:solidFill>
-                      <a:prstDash val="solid"/>
-                      <a:round/>
-                      <a:headEnd type="none" w="med" len="med"/>
-                      <a:tailEnd type="none" w="med" len="med"/>
-                    </a:lnR>
-                    <a:lnT w="12700" cap="flat" cmpd="sng" algn="ctr">
-                      <a:solidFill>
-                        <a:srgbClr val="FFFFFF"/>
-                      </a:solidFill>
-                      <a:prstDash val="solid"/>
-                      <a:round/>
-                      <a:headEnd type="none" w="med" len="med"/>
-                      <a:tailEnd type="none" w="med" len="med"/>
-                    </a:lnT>
-                    <a:lnB w="12700" cap="flat" cmpd="sng" algn="ctr">
-                      <a:solidFill>
-                        <a:srgbClr val="FFFFFF"/>
-                      </a:solidFill>
-                      <a:prstDash val="solid"/>
-                      <a:round/>
-                      <a:headEnd type="none" w="med" len="med"/>
-                      <a:tailEnd type="none" w="med" len="med"/>
-                    </a:lnB>
-                    <a:solidFill>
-                      <a:srgbClr val="FDF3E7"/>
-                    </a:solidFill>
-                  </a:tcPr>
-                </a:tc>
+              <a:tr h="146304">
                 <a:tc>
                   <a:txBody>
                     <a:bodyPr/>
@@ -16278,75 +16191,7 @@
                   </a:tcPr>
                 </a:tc>
               </a:tr>
-              <a:tr h="182880">
-                <a:tc>
-                  <a:txBody>
-                    <a:bodyPr/>
-                    <a:lstStyle/>
-                    <a:p>
-                      <a:pPr algn="ctr" indent="0" marL="0">
-                        <a:buNone/>
-                      </a:pPr>
-                      <a:r>
-                        <a:rPr lang="en-US" sz="1100" dirty="0">
-                          <a:solidFill>
-                            <a:srgbClr val="636E72"/>
-                          </a:solidFill>
-                          <a:latin typeface="Calibri" pitchFamily="34" charset="0"/>
-                          <a:ea typeface="Calibri" pitchFamily="34" charset="-122"/>
-                          <a:cs typeface="Calibri" pitchFamily="34" charset="-120"/>
-                        </a:rPr>
-                        <a:t>SDP 在干嘛</a:t>
-                      </a:r>
-                      <a:endParaRPr lang="en-US" sz="1100" dirty="0">
-                        <a:latin typeface="Calibri" charset="0"/>
-                        <a:ea typeface="Calibri" charset="0"/>
-                        <a:cs typeface="Calibri" charset="0"/>
-                      </a:endParaRPr>
-                    </a:p>
-                  </a:txBody>
-                  <a:tcPr marL="91440" marR="91440" marT="45720" marB="45720" anchor="ctr">
-                    <a:lnL w="12700" cap="flat" cmpd="sng" algn="ctr">
-                      <a:solidFill>
-                        <a:srgbClr val="FFFFFF"/>
-                      </a:solidFill>
-                      <a:prstDash val="solid"/>
-                      <a:round/>
-                      <a:headEnd type="none" w="med" len="med"/>
-                      <a:tailEnd type="none" w="med" len="med"/>
-                    </a:lnL>
-                    <a:lnR w="12700" cap="flat" cmpd="sng" algn="ctr">
-                      <a:solidFill>
-                        <a:srgbClr val="FFFFFF"/>
-                      </a:solidFill>
-                      <a:prstDash val="solid"/>
-                      <a:round/>
-                      <a:headEnd type="none" w="med" len="med"/>
-                      <a:tailEnd type="none" w="med" len="med"/>
-                    </a:lnR>
-                    <a:lnT w="12700" cap="flat" cmpd="sng" algn="ctr">
-                      <a:solidFill>
-                        <a:srgbClr val="FFFFFF"/>
-                      </a:solidFill>
-                      <a:prstDash val="solid"/>
-                      <a:round/>
-                      <a:headEnd type="none" w="med" len="med"/>
-                      <a:tailEnd type="none" w="med" len="med"/>
-                    </a:lnT>
-                    <a:lnB w="12700" cap="flat" cmpd="sng" algn="ctr">
-                      <a:solidFill>
-                        <a:srgbClr val="FFFFFF"/>
-                      </a:solidFill>
-                      <a:prstDash val="solid"/>
-                      <a:round/>
-                      <a:headEnd type="none" w="med" len="med"/>
-                      <a:tailEnd type="none" w="med" len="med"/>
-                    </a:lnB>
-                    <a:solidFill>
-                      <a:srgbClr val="FDF3E7"/>
-                    </a:solidFill>
-                  </a:tcPr>
-                </a:tc>
+              <a:tr h="146304">
                 <a:tc>
                   <a:txBody>
                     <a:bodyPr/>
@@ -16484,75 +16329,7 @@
                   </a:tcPr>
                 </a:tc>
               </a:tr>
-              <a:tr h="182880">
-                <a:tc>
-                  <a:txBody>
-                    <a:bodyPr/>
-                    <a:lstStyle/>
-                    <a:p>
-                      <a:pPr algn="ctr" indent="0" marL="0">
-                        <a:buNone/>
-                      </a:pPr>
-                      <a:r>
-                        <a:rPr lang="en-US" sz="1100" dirty="0">
-                          <a:solidFill>
-                            <a:srgbClr val="636E72"/>
-                          </a:solidFill>
-                          <a:latin typeface="Calibri" pitchFamily="34" charset="0"/>
-                          <a:ea typeface="Calibri" pitchFamily="34" charset="-122"/>
-                          <a:cs typeface="Calibri" pitchFamily="34" charset="-120"/>
-                        </a:rPr>
-                        <a:t>Loss</a:t>
-                      </a:r>
-                      <a:endParaRPr lang="en-US" sz="1100" dirty="0">
-                        <a:latin typeface="Calibri" charset="0"/>
-                        <a:ea typeface="Calibri" charset="0"/>
-                        <a:cs typeface="Calibri" charset="0"/>
-                      </a:endParaRPr>
-                    </a:p>
-                  </a:txBody>
-                  <a:tcPr marL="91440" marR="91440" marT="45720" marB="45720" anchor="ctr">
-                    <a:lnL w="12700" cap="flat" cmpd="sng" algn="ctr">
-                      <a:solidFill>
-                        <a:srgbClr val="FFFFFF"/>
-                      </a:solidFill>
-                      <a:prstDash val="solid"/>
-                      <a:round/>
-                      <a:headEnd type="none" w="med" len="med"/>
-                      <a:tailEnd type="none" w="med" len="med"/>
-                    </a:lnL>
-                    <a:lnR w="12700" cap="flat" cmpd="sng" algn="ctr">
-                      <a:solidFill>
-                        <a:srgbClr val="FFFFFF"/>
-                      </a:solidFill>
-                      <a:prstDash val="solid"/>
-                      <a:round/>
-                      <a:headEnd type="none" w="med" len="med"/>
-                      <a:tailEnd type="none" w="med" len="med"/>
-                    </a:lnR>
-                    <a:lnT w="12700" cap="flat" cmpd="sng" algn="ctr">
-                      <a:solidFill>
-                        <a:srgbClr val="FFFFFF"/>
-                      </a:solidFill>
-                      <a:prstDash val="solid"/>
-                      <a:round/>
-                      <a:headEnd type="none" w="med" len="med"/>
-                      <a:tailEnd type="none" w="med" len="med"/>
-                    </a:lnT>
-                    <a:lnB w="12700" cap="flat" cmpd="sng" algn="ctr">
-                      <a:solidFill>
-                        <a:srgbClr val="FFFFFF"/>
-                      </a:solidFill>
-                      <a:prstDash val="solid"/>
-                      <a:round/>
-                      <a:headEnd type="none" w="med" len="med"/>
-                      <a:tailEnd type="none" w="med" len="med"/>
-                    </a:lnB>
-                    <a:solidFill>
-                      <a:srgbClr val="FDF3E7"/>
-                    </a:solidFill>
-                  </a:tcPr>
-                </a:tc>
+              <a:tr h="146304">
                 <a:tc>
                   <a:txBody>
                     <a:bodyPr/>
@@ -17164,7 +16941,7 @@
         <p:spPr>
           <a:xfrm>
             <a:off x="457200" y="1463040"/>
-            <a:ext cx="4023360" cy="1097280"/>
+            <a:ext cx="4023360" cy="914400"/>
           </a:xfrm>
           <a:prstGeom prst="rect">
             <a:avLst/>
@@ -17288,7 +17065,7 @@
         <p:spPr>
           <a:xfrm>
             <a:off x="4754880" y="1463040"/>
-            <a:ext cx="4023360" cy="1097280"/>
+            <a:ext cx="4023360" cy="914400"/>
           </a:xfrm>
           <a:prstGeom prst="rect">
             <a:avLst/>
@@ -17431,7 +17208,7 @@
         </p:nvSpPr>
         <p:spPr>
           <a:xfrm>
-            <a:off x="457200" y="2788920"/>
+            <a:off x="457200" y="2560320"/>
             <a:ext cx="8229600" cy="320040"/>
           </a:xfrm>
           <a:prstGeom prst="rect">
@@ -17470,8 +17247,8 @@
         </p:nvSpPr>
         <p:spPr>
           <a:xfrm>
-            <a:off x="457200" y="3154680"/>
-            <a:ext cx="8229600" cy="1645920"/>
+            <a:off x="457200" y="2926080"/>
+            <a:ext cx="8229600" cy="1417320"/>
           </a:xfrm>
           <a:prstGeom prst="rect">
             <a:avLst/>
@@ -17497,8 +17274,8 @@
         </p:nvSpPr>
         <p:spPr>
           <a:xfrm>
-            <a:off x="731520" y="3200400"/>
-            <a:ext cx="7680960" cy="1188720"/>
+            <a:off x="731520" y="2971800"/>
+            <a:ext cx="7680960" cy="1051560"/>
           </a:xfrm>
           <a:prstGeom prst="rect">
             <a:avLst/>
@@ -17660,7 +17437,7 @@
         </p:nvSpPr>
         <p:spPr>
           <a:xfrm>
-            <a:off x="457200" y="4434840"/>
+            <a:off x="457200" y="4389120"/>
             <a:ext cx="8229600" cy="228600"/>
           </a:xfrm>
           <a:prstGeom prst="rect">
@@ -20075,20 +19852,98 @@
       </p:sp>
       <p:sp>
         <p:nvSpPr>
-          <p:cNvPr id="21" name="Shape 19"/>
-          <p:cNvSpPr/>
-          <p:nvPr/>
-        </p:nvSpPr>
-        <p:spPr>
-          <a:xfrm>
-            <a:off x="2560320" y="1417320"/>
-            <a:ext cx="4023360" cy="594360"/>
-          </a:xfrm>
-          <a:prstGeom prst="rect">
-            <a:avLst/>
-          </a:prstGeom>
-          <a:solidFill>
-            <a:srgbClr val="FFFFFF"/>
+          <p:cNvPr id="21" name="Text 19"/>
+          <p:cNvSpPr/>
+          <p:nvPr/>
+        </p:nvSpPr>
+        <p:spPr>
+          <a:xfrm>
+            <a:off x="2926080" y="1965960"/>
+            <a:ext cx="1097280" cy="457200"/>
+          </a:xfrm>
+          <a:prstGeom prst="rect">
+            <a:avLst/>
+          </a:prstGeom>
+          <a:noFill/>
+          <a:ln/>
+        </p:spPr>
+        <p:txBody>
+          <a:bodyPr wrap="square" lIns="0" tIns="0" rIns="0" bIns="0" rtlCol="0" anchor="ctr"/>
+          <a:lstStyle/>
+          <a:p>
+            <a:pPr algn="ctr" indent="0" marL="0">
+              <a:buNone/>
+            </a:pPr>
+            <a:r>
+              <a:rPr lang="en-US" sz="2000" dirty="0">
+                <a:solidFill>
+                  <a:srgbClr val="F0A500"/>
+                </a:solidFill>
+                <a:latin typeface="Consolas" pitchFamily="34" charset="0"/>
+                <a:ea typeface="Consolas" pitchFamily="34" charset="-122"/>
+                <a:cs typeface="Consolas" pitchFamily="34" charset="-120"/>
+              </a:rPr>
+              <a:t>┌</a:t>
+            </a:r>
+            <a:endParaRPr lang="en-US" sz="2000" dirty="0"/>
+          </a:p>
+        </p:txBody>
+      </p:sp>
+      <p:sp>
+        <p:nvSpPr>
+          <p:cNvPr id="22" name="Text 20"/>
+          <p:cNvSpPr/>
+          <p:nvPr/>
+        </p:nvSpPr>
+        <p:spPr>
+          <a:xfrm>
+            <a:off x="5120640" y="1965960"/>
+            <a:ext cx="1097280" cy="457200"/>
+          </a:xfrm>
+          <a:prstGeom prst="rect">
+            <a:avLst/>
+          </a:prstGeom>
+          <a:noFill/>
+          <a:ln/>
+        </p:spPr>
+        <p:txBody>
+          <a:bodyPr wrap="square" lIns="0" tIns="0" rIns="0" bIns="0" rtlCol="0" anchor="ctr"/>
+          <a:lstStyle/>
+          <a:p>
+            <a:pPr algn="ctr" indent="0" marL="0">
+              <a:buNone/>
+            </a:pPr>
+            <a:r>
+              <a:rPr lang="en-US" sz="2000" dirty="0">
+                <a:solidFill>
+                  <a:srgbClr val="F0A500"/>
+                </a:solidFill>
+                <a:latin typeface="Consolas" pitchFamily="34" charset="0"/>
+                <a:ea typeface="Consolas" pitchFamily="34" charset="-122"/>
+                <a:cs typeface="Consolas" pitchFamily="34" charset="-120"/>
+              </a:rPr>
+              <a:t>┐</a:t>
+            </a:r>
+            <a:endParaRPr lang="en-US" sz="2000" dirty="0"/>
+          </a:p>
+        </p:txBody>
+      </p:sp>
+      <p:sp>
+        <p:nvSpPr>
+          <p:cNvPr id="23" name="Shape 21"/>
+          <p:cNvSpPr/>
+          <p:nvPr/>
+        </p:nvSpPr>
+        <p:spPr>
+          <a:xfrm>
+            <a:off x="457200" y="2468880"/>
+            <a:ext cx="4023360" cy="1463040"/>
+          </a:xfrm>
+          <a:prstGeom prst="rect">
+            <a:avLst/>
+          </a:prstGeom>
+          <a:solidFill>
+            <a:srgbClr val="FDF3E7"/>
           </a:solidFill>
           <a:ln/>
           <a:effectLst>
@@ -20102,119 +19957,167 @@
       </p:sp>
       <p:sp>
         <p:nvSpPr>
-          <p:cNvPr id="22" name="Text 20"/>
-          <p:cNvSpPr/>
-          <p:nvPr/>
-        </p:nvSpPr>
-        <p:spPr>
-          <a:xfrm>
-            <a:off x="2560320" y="1417320"/>
-            <a:ext cx="4023360" cy="594360"/>
-          </a:xfrm>
-          <a:prstGeom prst="rect">
-            <a:avLst/>
-          </a:prstGeom>
-          <a:noFill/>
-          <a:ln/>
-        </p:spPr>
-        <p:txBody>
-          <a:bodyPr wrap="square" lIns="50800" tIns="50800" rIns="50800" bIns="50800" rtlCol="0" anchor="ctr"/>
-          <a:lstStyle/>
-          <a:p>
-            <a:pPr algn="ctr" indent="0" marL="0">
+          <p:cNvPr id="24" name="Shape 22"/>
+          <p:cNvSpPr/>
+          <p:nvPr/>
+        </p:nvSpPr>
+        <p:spPr>
+          <a:xfrm>
+            <a:off x="457200" y="2468880"/>
+            <a:ext cx="4023360" cy="36576"/>
+          </a:xfrm>
+          <a:prstGeom prst="rect">
+            <a:avLst/>
+          </a:prstGeom>
+          <a:solidFill>
+            <a:srgbClr val="F0A500"/>
+          </a:solidFill>
+          <a:ln/>
+        </p:spPr>
+      </p:sp>
+      <p:sp>
+        <p:nvSpPr>
+          <p:cNvPr id="25" name="Text 23"/>
+          <p:cNvSpPr/>
+          <p:nvPr/>
+        </p:nvSpPr>
+        <p:spPr>
+          <a:xfrm>
+            <a:off x="640080" y="2606040"/>
+            <a:ext cx="3657600" cy="365760"/>
+          </a:xfrm>
+          <a:prstGeom prst="rect">
+            <a:avLst/>
+          </a:prstGeom>
+          <a:noFill/>
+          <a:ln/>
+        </p:spPr>
+        <p:txBody>
+          <a:bodyPr wrap="square" lIns="0" tIns="0" rIns="0" bIns="0" rtlCol="0" anchor="ctr"/>
+          <a:lstStyle/>
+          <a:p>
+            <a:pPr indent="0" marL="0">
               <a:buNone/>
             </a:pPr>
+            <a:r>
+              <a:rPr lang="en-US" sz="2000" b="1" dirty="0">
+                <a:solidFill>
+                  <a:srgbClr val="2D3436"/>
+                </a:solidFill>
+                <a:latin typeface="Georgia" pitchFamily="34" charset="0"/>
+                <a:ea typeface="Georgia" pitchFamily="34" charset="-122"/>
+                <a:cs typeface="Georgia" pitchFamily="34" charset="-120"/>
+              </a:rPr>
+              <a:t>CosyVoice</a:t>
+            </a:r>
+            <a:endParaRPr lang="en-US" sz="2000" dirty="0"/>
+          </a:p>
+        </p:txBody>
+      </p:sp>
+      <p:sp>
+        <p:nvSpPr>
+          <p:cNvPr id="26" name="Text 24"/>
+          <p:cNvSpPr/>
+          <p:nvPr/>
+        </p:nvSpPr>
+        <p:spPr>
+          <a:xfrm>
+            <a:off x="640080" y="2971800"/>
+            <a:ext cx="3657600" cy="274320"/>
+          </a:xfrm>
+          <a:prstGeom prst="rect">
+            <a:avLst/>
+          </a:prstGeom>
+          <a:noFill/>
+          <a:ln/>
+        </p:spPr>
+        <p:txBody>
+          <a:bodyPr wrap="square" lIns="0" tIns="0" rIns="0" bIns="0" rtlCol="0" anchor="ctr"/>
+          <a:lstStyle/>
+          <a:p>
+            <a:pPr indent="0" marL="0">
+              <a:buNone/>
+            </a:pPr>
+            <a:r>
+              <a:rPr lang="en-US" sz="1400" dirty="0">
+                <a:solidFill>
+                  <a:srgbClr val="F0A500"/>
+                </a:solidFill>
+                <a:latin typeface="Calibri" pitchFamily="34" charset="0"/>
+                <a:ea typeface="Calibri" pitchFamily="34" charset="-122"/>
+                <a:cs typeface="Calibri" pitchFamily="34" charset="-120"/>
+              </a:rPr>
+              <a:t>Flow Matching + 连续表示</a:t>
+            </a:r>
+            <a:endParaRPr lang="en-US" sz="1400" dirty="0"/>
+          </a:p>
+        </p:txBody>
+      </p:sp>
+      <p:sp>
+        <p:nvSpPr>
+          <p:cNvPr id="27" name="Text 25"/>
+          <p:cNvSpPr/>
+          <p:nvPr/>
+        </p:nvSpPr>
+        <p:spPr>
+          <a:xfrm>
+            <a:off x="640080" y="3291840"/>
+            <a:ext cx="3657600" cy="502920"/>
+          </a:xfrm>
+          <a:prstGeom prst="rect">
+            <a:avLst/>
+          </a:prstGeom>
+          <a:noFill/>
+          <a:ln/>
+        </p:spPr>
+        <p:txBody>
+          <a:bodyPr wrap="square" lIns="0" tIns="0" rIns="0" bIns="0" rtlCol="0" anchor="ctr"/>
+          <a:lstStyle/>
+          <a:p>
+            <a:pPr indent="0" marL="0">
+              <a:buNone/>
+            </a:pPr>
+            <a:r>
+              <a:rPr lang="en-US" sz="1200" dirty="0">
+                <a:solidFill>
+                  <a:srgbClr val="9CA3A8"/>
+                </a:solidFill>
+                <a:latin typeface="Calibri" pitchFamily="34" charset="0"/>
+                <a:ea typeface="Calibri" pitchFamily="34" charset="-122"/>
+                <a:cs typeface="Calibri" pitchFamily="34" charset="-120"/>
+              </a:rPr>
+              <a:t>质量上限高，架构自由</a:t>
+            </a:r>
             <a:endParaRPr lang="en-US" sz="1200" dirty="0"/>
           </a:p>
-        </p:txBody>
-      </p:sp>
-      <p:sp>
-        <p:nvSpPr>
-          <p:cNvPr id="23" name="Text 21"/>
-          <p:cNvSpPr/>
-          <p:nvPr/>
-        </p:nvSpPr>
-        <p:spPr>
-          <a:xfrm>
-            <a:off x="2926080" y="1965960"/>
-            <a:ext cx="1097280" cy="457200"/>
-          </a:xfrm>
-          <a:prstGeom prst="rect">
-            <a:avLst/>
-          </a:prstGeom>
-          <a:noFill/>
-          <a:ln/>
-        </p:spPr>
-        <p:txBody>
-          <a:bodyPr wrap="square" lIns="0" tIns="0" rIns="0" bIns="0" rtlCol="0" anchor="ctr"/>
-          <a:lstStyle/>
-          <a:p>
-            <a:pPr algn="ctr" indent="0" marL="0">
+          <a:p>
+            <a:pPr indent="0" marL="0">
               <a:buNone/>
             </a:pPr>
             <a:r>
-              <a:rPr lang="en-US" sz="2000" dirty="0">
-                <a:solidFill>
-                  <a:srgbClr val="F0A500"/>
-                </a:solidFill>
-                <a:latin typeface="Consolas" pitchFamily="34" charset="0"/>
-                <a:ea typeface="Consolas" pitchFamily="34" charset="-122"/>
-                <a:cs typeface="Consolas" pitchFamily="34" charset="-120"/>
-              </a:rPr>
-              <a:t>┌</a:t>
-            </a:r>
-            <a:endParaRPr lang="en-US" sz="2000" dirty="0"/>
-          </a:p>
-        </p:txBody>
-      </p:sp>
-      <p:sp>
-        <p:nvSpPr>
-          <p:cNvPr id="24" name="Text 22"/>
-          <p:cNvSpPr/>
-          <p:nvPr/>
-        </p:nvSpPr>
-        <p:spPr>
-          <a:xfrm>
-            <a:off x="5120640" y="1965960"/>
-            <a:ext cx="1097280" cy="457200"/>
-          </a:xfrm>
-          <a:prstGeom prst="rect">
-            <a:avLst/>
-          </a:prstGeom>
-          <a:noFill/>
-          <a:ln/>
-        </p:spPr>
-        <p:txBody>
-          <a:bodyPr wrap="square" lIns="0" tIns="0" rIns="0" bIns="0" rtlCol="0" anchor="ctr"/>
-          <a:lstStyle/>
-          <a:p>
-            <a:pPr algn="ctr" indent="0" marL="0">
-              <a:buNone/>
-            </a:pPr>
-            <a:r>
-              <a:rPr lang="en-US" sz="2000" dirty="0">
-                <a:solidFill>
-                  <a:srgbClr val="F0A500"/>
-                </a:solidFill>
-                <a:latin typeface="Consolas" pitchFamily="34" charset="0"/>
-                <a:ea typeface="Consolas" pitchFamily="34" charset="-122"/>
-                <a:cs typeface="Consolas" pitchFamily="34" charset="-120"/>
-              </a:rPr>
-              <a:t>┐</a:t>
-            </a:r>
-            <a:endParaRPr lang="en-US" sz="2000" dirty="0"/>
-          </a:p>
-        </p:txBody>
-      </p:sp>
-      <p:sp>
-        <p:nvSpPr>
-          <p:cNvPr id="25" name="Shape 23"/>
-          <p:cNvSpPr/>
-          <p:nvPr/>
-        </p:nvSpPr>
-        <p:spPr>
-          <a:xfrm>
-            <a:off x="457200" y="2468880"/>
+              <a:rPr lang="en-US" sz="1200" dirty="0">
+                <a:solidFill>
+                  <a:srgbClr val="9CA3A8"/>
+                </a:solidFill>
+                <a:latin typeface="Calibri" pitchFamily="34" charset="0"/>
+                <a:ea typeface="Calibri" pitchFamily="34" charset="-122"/>
+                <a:cs typeface="Calibri" pitchFamily="34" charset="-120"/>
+              </a:rPr>
+              <a:t>可用 Transformer</a:t>
+            </a:r>
+            <a:endParaRPr lang="en-US" sz="1200" dirty="0"/>
+          </a:p>
+        </p:txBody>
+      </p:sp>
+      <p:sp>
+        <p:nvSpPr>
+          <p:cNvPr id="28" name="Shape 26"/>
+          <p:cNvSpPr/>
+          <p:nvPr/>
+        </p:nvSpPr>
+        <p:spPr>
+          <a:xfrm>
+            <a:off x="4754880" y="2468880"/>
             <a:ext cx="4023360" cy="1463040"/>
           </a:xfrm>
           <a:prstGeom prst="rect">
@@ -20235,13 +20138,13 @@
       </p:sp>
       <p:sp>
         <p:nvSpPr>
-          <p:cNvPr id="26" name="Shape 24"/>
-          <p:cNvSpPr/>
-          <p:nvPr/>
-        </p:nvSpPr>
-        <p:spPr>
-          <a:xfrm>
-            <a:off x="457200" y="2468880"/>
+          <p:cNvPr id="29" name="Shape 27"/>
+          <p:cNvSpPr/>
+          <p:nvPr/>
+        </p:nvSpPr>
+        <p:spPr>
+          <a:xfrm>
+            <a:off x="4754880" y="2468880"/>
             <a:ext cx="4023360" cy="36576"/>
           </a:xfrm>
           <a:prstGeom prst="rect">
@@ -20255,13 +20158,13 @@
       </p:sp>
       <p:sp>
         <p:nvSpPr>
-          <p:cNvPr id="27" name="Text 25"/>
-          <p:cNvSpPr/>
-          <p:nvPr/>
-        </p:nvSpPr>
-        <p:spPr>
-          <a:xfrm>
-            <a:off x="640080" y="2606040"/>
+          <p:cNvPr id="30" name="Text 28"/>
+          <p:cNvSpPr/>
+          <p:nvPr/>
+        </p:nvSpPr>
+        <p:spPr>
+          <a:xfrm>
+            <a:off x="4937760" y="2606040"/>
             <a:ext cx="3657600" cy="365760"/>
           </a:xfrm>
           <a:prstGeom prst="rect">
@@ -20286,7 +20189,7 @@
                 <a:ea typeface="Georgia" pitchFamily="34" charset="-122"/>
                 <a:cs typeface="Georgia" pitchFamily="34" charset="-120"/>
               </a:rPr>
-              <a:t>CosyVoice</a:t>
+              <a:t>FishSpeech</a:t>
             </a:r>
             <a:endParaRPr lang="en-US" sz="2000" dirty="0"/>
           </a:p>
@@ -20294,13 +20197,13 @@
       </p:sp>
       <p:sp>
         <p:nvSpPr>
-          <p:cNvPr id="28" name="Text 26"/>
-          <p:cNvSpPr/>
-          <p:nvPr/>
-        </p:nvSpPr>
-        <p:spPr>
-          <a:xfrm>
-            <a:off x="640080" y="2971800"/>
+          <p:cNvPr id="31" name="Text 29"/>
+          <p:cNvSpPr/>
+          <p:nvPr/>
+        </p:nvSpPr>
+        <p:spPr>
+          <a:xfrm>
+            <a:off x="4937760" y="2971800"/>
             <a:ext cx="3657600" cy="274320"/>
           </a:xfrm>
           <a:prstGeom prst="rect">
@@ -20325,7 +20228,7 @@
                 <a:ea typeface="Calibri" pitchFamily="34" charset="-122"/>
                 <a:cs typeface="Calibri" pitchFamily="34" charset="-120"/>
               </a:rPr>
-              <a:t>Flow Matching + 连续表示</a:t>
+              <a:t>离散 token + LLM</a:t>
             </a:r>
             <a:endParaRPr lang="en-US" sz="1400" dirty="0"/>
           </a:p>
@@ -20333,13 +20236,13 @@
       </p:sp>
       <p:sp>
         <p:nvSpPr>
-          <p:cNvPr id="29" name="Text 27"/>
-          <p:cNvSpPr/>
-          <p:nvPr/>
-        </p:nvSpPr>
-        <p:spPr>
-          <a:xfrm>
-            <a:off x="640080" y="3291840"/>
+          <p:cNvPr id="32" name="Text 30"/>
+          <p:cNvSpPr/>
+          <p:nvPr/>
+        </p:nvSpPr>
+        <p:spPr>
+          <a:xfrm>
+            <a:off x="4937760" y="3291840"/>
             <a:ext cx="3657600" cy="502920"/>
           </a:xfrm>
           <a:prstGeom prst="rect">
@@ -20364,7 +20267,7 @@
                 <a:ea typeface="Calibri" pitchFamily="34" charset="-122"/>
                 <a:cs typeface="Calibri" pitchFamily="34" charset="-120"/>
               </a:rPr>
-              <a:t>质量上限高，架构自由</a:t>
+              <a:t>享受 Scaling Law</a:t>
             </a:r>
             <a:endParaRPr lang="en-US" sz="1200" dirty="0"/>
           </a:p>
@@ -20381,7 +20284,7 @@
                 <a:ea typeface="Calibri" pitchFamily="34" charset="-122"/>
                 <a:cs typeface="Calibri" pitchFamily="34" charset="-120"/>
               </a:rPr>
-              <a:t>可用 Transformer</a:t>
+              <a:t>可扩展</a:t>
             </a:r>
             <a:endParaRPr lang="en-US" sz="1200" dirty="0"/>
           </a:p>
@@ -20389,61 +20292,14 @@
       </p:sp>
       <p:sp>
         <p:nvSpPr>
-          <p:cNvPr id="30" name="Shape 28"/>
-          <p:cNvSpPr/>
-          <p:nvPr/>
-        </p:nvSpPr>
-        <p:spPr>
-          <a:xfrm>
-            <a:off x="4754880" y="2468880"/>
-            <a:ext cx="4023360" cy="1463040"/>
-          </a:xfrm>
-          <a:prstGeom prst="rect">
-            <a:avLst/>
-          </a:prstGeom>
-          <a:solidFill>
-            <a:srgbClr val="FDF3E7"/>
-          </a:solidFill>
-          <a:ln/>
-          <a:effectLst>
-            <a:outerShdw sx="100000" sy="100000" kx="0" ky="0" algn="bl" rotWithShape="0" blurRad="127000" dist="25400" dir="8100000">
-              <a:srgbClr val="000000">
-                <a:alpha val="8000"/>
-              </a:srgbClr>
-            </a:outerShdw>
-          </a:effectLst>
-        </p:spPr>
-      </p:sp>
-      <p:sp>
-        <p:nvSpPr>
-          <p:cNvPr id="31" name="Shape 29"/>
-          <p:cNvSpPr/>
-          <p:nvPr/>
-        </p:nvSpPr>
-        <p:spPr>
-          <a:xfrm>
-            <a:off x="4754880" y="2468880"/>
-            <a:ext cx="4023360" cy="36576"/>
-          </a:xfrm>
-          <a:prstGeom prst="rect">
-            <a:avLst/>
-          </a:prstGeom>
-          <a:solidFill>
-            <a:srgbClr val="F0A500"/>
-          </a:solidFill>
-          <a:ln/>
-        </p:spPr>
-      </p:sp>
-      <p:sp>
-        <p:nvSpPr>
-          <p:cNvPr id="32" name="Text 30"/>
-          <p:cNvSpPr/>
-          <p:nvPr/>
-        </p:nvSpPr>
-        <p:spPr>
-          <a:xfrm>
-            <a:off x="4937760" y="2606040"/>
-            <a:ext cx="3657600" cy="365760"/>
+          <p:cNvPr id="33" name="Text 31"/>
+          <p:cNvSpPr/>
+          <p:nvPr/>
+        </p:nvSpPr>
+        <p:spPr>
+          <a:xfrm>
+            <a:off x="457200" y="3931920"/>
+            <a:ext cx="8229600" cy="274320"/>
           </a:xfrm>
           <a:prstGeom prst="rect">
             <a:avLst/>
@@ -20459,7 +20315,7 @@
               <a:buNone/>
             </a:pPr>
             <a:r>
-              <a:rPr lang="en-US" sz="2000" b="1" dirty="0">
+              <a:rPr lang="en-US" sz="1400" b="1" dirty="0">
                 <a:solidFill>
                   <a:srgbClr val="2D3436"/>
                 </a:solidFill>
@@ -20467,46 +20323,7 @@
                 <a:ea typeface="Georgia" pitchFamily="34" charset="-122"/>
                 <a:cs typeface="Georgia" pitchFamily="34" charset="-120"/>
               </a:rPr>
-              <a:t>FishSpeech</a:t>
-            </a:r>
-            <a:endParaRPr lang="en-US" sz="2000" dirty="0"/>
-          </a:p>
-        </p:txBody>
-      </p:sp>
-      <p:sp>
-        <p:nvSpPr>
-          <p:cNvPr id="33" name="Text 31"/>
-          <p:cNvSpPr/>
-          <p:nvPr/>
-        </p:nvSpPr>
-        <p:spPr>
-          <a:xfrm>
-            <a:off x="4937760" y="2971800"/>
-            <a:ext cx="3657600" cy="274320"/>
-          </a:xfrm>
-          <a:prstGeom prst="rect">
-            <a:avLst/>
-          </a:prstGeom>
-          <a:noFill/>
-          <a:ln/>
-        </p:spPr>
-        <p:txBody>
-          <a:bodyPr wrap="square" lIns="0" tIns="0" rIns="0" bIns="0" rtlCol="0" anchor="ctr"/>
-          <a:lstStyle/>
-          <a:p>
-            <a:pPr indent="0" marL="0">
-              <a:buNone/>
-            </a:pPr>
-            <a:r>
-              <a:rPr lang="en-US" sz="1400" dirty="0">
-                <a:solidFill>
-                  <a:srgbClr val="F0A500"/>
-                </a:solidFill>
-                <a:latin typeface="Calibri" pitchFamily="34" charset="0"/>
-                <a:ea typeface="Calibri" pitchFamily="34" charset="-122"/>
-                <a:cs typeface="Calibri" pitchFamily="34" charset="-120"/>
-              </a:rPr>
-              <a:t>离散 token + LLM</a:t>
+              <a:t>三条路线演化</a:t>
             </a:r>
             <a:endParaRPr lang="en-US" sz="1400" dirty="0"/>
           </a:p>
@@ -20515,101 +20332,6 @@
       <p:sp>
         <p:nvSpPr>
           <p:cNvPr id="34" name="Text 32"/>
-          <p:cNvSpPr/>
-          <p:nvPr/>
-        </p:nvSpPr>
-        <p:spPr>
-          <a:xfrm>
-            <a:off x="4937760" y="3291840"/>
-            <a:ext cx="3657600" cy="502920"/>
-          </a:xfrm>
-          <a:prstGeom prst="rect">
-            <a:avLst/>
-          </a:prstGeom>
-          <a:noFill/>
-          <a:ln/>
-        </p:spPr>
-        <p:txBody>
-          <a:bodyPr wrap="square" lIns="0" tIns="0" rIns="0" bIns="0" rtlCol="0" anchor="ctr"/>
-          <a:lstStyle/>
-          <a:p>
-            <a:pPr indent="0" marL="0">
-              <a:buNone/>
-            </a:pPr>
-            <a:r>
-              <a:rPr lang="en-US" sz="1200" dirty="0">
-                <a:solidFill>
-                  <a:srgbClr val="9CA3A8"/>
-                </a:solidFill>
-                <a:latin typeface="Calibri" pitchFamily="34" charset="0"/>
-                <a:ea typeface="Calibri" pitchFamily="34" charset="-122"/>
-                <a:cs typeface="Calibri" pitchFamily="34" charset="-120"/>
-              </a:rPr>
-              <a:t>享受 Scaling Law</a:t>
-            </a:r>
-            <a:endParaRPr lang="en-US" sz="1200" dirty="0"/>
-          </a:p>
-          <a:p>
-            <a:pPr indent="0" marL="0">
-              <a:buNone/>
-            </a:pPr>
-            <a:r>
-              <a:rPr lang="en-US" sz="1200" dirty="0">
-                <a:solidFill>
-                  <a:srgbClr val="9CA3A8"/>
-                </a:solidFill>
-                <a:latin typeface="Calibri" pitchFamily="34" charset="0"/>
-                <a:ea typeface="Calibri" pitchFamily="34" charset="-122"/>
-                <a:cs typeface="Calibri" pitchFamily="34" charset="-120"/>
-              </a:rPr>
-              <a:t>可扩展</a:t>
-            </a:r>
-            <a:endParaRPr lang="en-US" sz="1200" dirty="0"/>
-          </a:p>
-        </p:txBody>
-      </p:sp>
-      <p:sp>
-        <p:nvSpPr>
-          <p:cNvPr id="35" name="Text 33"/>
-          <p:cNvSpPr/>
-          <p:nvPr/>
-        </p:nvSpPr>
-        <p:spPr>
-          <a:xfrm>
-            <a:off x="457200" y="3931920"/>
-            <a:ext cx="8229600" cy="274320"/>
-          </a:xfrm>
-          <a:prstGeom prst="rect">
-            <a:avLst/>
-          </a:prstGeom>
-          <a:noFill/>
-          <a:ln/>
-        </p:spPr>
-        <p:txBody>
-          <a:bodyPr wrap="square" lIns="0" tIns="0" rIns="0" bIns="0" rtlCol="0" anchor="ctr"/>
-          <a:lstStyle/>
-          <a:p>
-            <a:pPr indent="0" marL="0">
-              <a:buNone/>
-            </a:pPr>
-            <a:r>
-              <a:rPr lang="en-US" sz="1400" b="1" dirty="0">
-                <a:solidFill>
-                  <a:srgbClr val="2D3436"/>
-                </a:solidFill>
-                <a:latin typeface="Georgia" pitchFamily="34" charset="0"/>
-                <a:ea typeface="Georgia" pitchFamily="34" charset="-122"/>
-                <a:cs typeface="Georgia" pitchFamily="34" charset="-120"/>
-              </a:rPr>
-              <a:t>三条路线演化</a:t>
-            </a:r>
-            <a:endParaRPr lang="en-US" sz="1400" dirty="0"/>
-          </a:p>
-        </p:txBody>
-      </p:sp>
-      <p:sp>
-        <p:nvSpPr>
-          <p:cNvPr id="36" name="Text 34"/>
           <p:cNvSpPr/>
           <p:nvPr/>
         </p:nvSpPr>
@@ -22280,85 +22002,7 @@
         </p:nvSpPr>
         <p:spPr>
           <a:xfrm>
-            <a:off x="457200" y="3337560"/>
-            <a:ext cx="8229600" cy="320040"/>
-          </a:xfrm>
-          <a:prstGeom prst="rect">
-            <a:avLst/>
-          </a:prstGeom>
-          <a:noFill/>
-          <a:ln/>
-        </p:spPr>
-        <p:txBody>
-          <a:bodyPr wrap="square" lIns="0" tIns="0" rIns="0" bIns="0" rtlCol="0" anchor="ctr"/>
-          <a:lstStyle/>
-          <a:p>
-            <a:pPr algn="ctr" indent="0" marL="0">
-              <a:buNone/>
-            </a:pPr>
-            <a:r>
-              <a:rPr lang="en-US" sz="1600" b="1" dirty="0">
-                <a:solidFill>
-                  <a:srgbClr val="2D3436"/>
-                </a:solidFill>
-                <a:latin typeface="Georgia" pitchFamily="34" charset="0"/>
-                <a:ea typeface="Georgia" pitchFamily="34" charset="-122"/>
-                <a:cs typeface="Georgia" pitchFamily="34" charset="-120"/>
-              </a:rPr>
-              <a:t>完整链路</a:t>
-            </a:r>
-            <a:endParaRPr lang="en-US" sz="1600" dirty="0"/>
-          </a:p>
-        </p:txBody>
-      </p:sp>
-      <p:sp>
-        <p:nvSpPr>
-          <p:cNvPr id="22" name="Text 19"/>
-          <p:cNvSpPr/>
-          <p:nvPr/>
-        </p:nvSpPr>
-        <p:spPr>
-          <a:xfrm>
-            <a:off x="457200" y="3749040"/>
-            <a:ext cx="8229600" cy="411480"/>
-          </a:xfrm>
-          <a:prstGeom prst="rect">
-            <a:avLst/>
-          </a:prstGeom>
-          <a:noFill/>
-          <a:ln/>
-        </p:spPr>
-        <p:txBody>
-          <a:bodyPr wrap="square" lIns="0" tIns="0" rIns="0" bIns="0" rtlCol="0" anchor="ctr"/>
-          <a:lstStyle/>
-          <a:p>
-            <a:pPr algn="ctr" indent="0" marL="0">
-              <a:buNone/>
-            </a:pPr>
-            <a:r>
-              <a:rPr lang="en-US" sz="1400" dirty="0">
-                <a:solidFill>
-                  <a:srgbClr val="F0A500"/>
-                </a:solidFill>
-                <a:latin typeface="Consolas" pitchFamily="34" charset="0"/>
-                <a:ea typeface="Consolas" pitchFamily="34" charset="-122"/>
-                <a:cs typeface="Consolas" pitchFamily="34" charset="-120"/>
-              </a:rPr>
-              <a:t>「大家好」 → 音素 /d/a/j/i/a/h/a/o/ → TextEncoder → z → HiFi-GAN → 波形 ✓</a:t>
-            </a:r>
-            <a:endParaRPr lang="en-US" sz="1400" dirty="0"/>
-          </a:p>
-        </p:txBody>
-      </p:sp>
-      <p:sp>
-        <p:nvSpPr>
-          <p:cNvPr id="23" name="Text 20"/>
-          <p:cNvSpPr/>
-          <p:nvPr/>
-        </p:nvSpPr>
-        <p:spPr>
-          <a:xfrm>
-            <a:off x="457200" y="4114800"/>
+            <a:off x="457200" y="3474720"/>
             <a:ext cx="8229600" cy="320040"/>
           </a:xfrm>
           <a:prstGeom prst="rect">
@@ -24340,7 +23984,7 @@
         <p:spPr>
           <a:xfrm>
             <a:off x="457200" y="1463040"/>
-            <a:ext cx="3931920" cy="2926080"/>
+            <a:ext cx="3931920" cy="3200400"/>
           </a:xfrm>
           <a:prstGeom prst="rect">
             <a:avLst/>
@@ -24367,7 +24011,7 @@
         <p:spPr>
           <a:xfrm>
             <a:off x="457200" y="1463040"/>
-            <a:ext cx="54864" cy="2926080"/>
+            <a:ext cx="54864" cy="3200400"/>
           </a:xfrm>
           <a:prstGeom prst="rect">
             <a:avLst/>
@@ -24387,7 +24031,7 @@
         <p:spPr>
           <a:xfrm>
             <a:off x="731520" y="1600200"/>
-            <a:ext cx="3474720" cy="411480"/>
+            <a:ext cx="3474720" cy="320040"/>
           </a:xfrm>
           <a:prstGeom prst="rect">
             <a:avLst/>
@@ -24403,7 +24047,7 @@
               <a:buNone/>
             </a:pPr>
             <a:r>
-              <a:rPr lang="en-US" sz="1800" b="1" dirty="0">
+              <a:rPr lang="en-US" sz="1600" b="1" dirty="0">
                 <a:solidFill>
                   <a:srgbClr val="2D3436"/>
                 </a:solidFill>
@@ -24413,7 +24057,7 @@
               </a:rPr>
               <a:t>波形 Waveform</a:t>
             </a:r>
-            <a:endParaRPr lang="en-US" sz="1800" dirty="0"/>
+            <a:endParaRPr lang="en-US" sz="1600" dirty="0"/>
           </a:p>
         </p:txBody>
       </p:sp>
@@ -24425,8 +24069,8 @@
         </p:nvSpPr>
         <p:spPr>
           <a:xfrm>
-            <a:off x="731520" y="2103120"/>
-            <a:ext cx="3474720" cy="2103120"/>
+            <a:off x="731520" y="1965960"/>
+            <a:ext cx="3474720" cy="1005840"/>
           </a:xfrm>
           <a:prstGeom prst="rect">
             <a:avLst/>
@@ -24443,7 +24087,7 @@
               <a:buChar char="•"/>
             </a:pPr>
             <a:r>
-              <a:rPr lang="en-US" sz="1400" dirty="0">
+              <a:rPr lang="en-US" sz="1200" dirty="0">
                 <a:solidFill>
                   <a:srgbClr val="636E72"/>
                 </a:solidFill>
@@ -24453,7 +24097,7 @@
               </a:rPr>
               <a:t>横轴 = 时间，纵轴 = 振幅</a:t>
             </a:r>
-            <a:endParaRPr lang="en-US" sz="1400" dirty="0"/>
+            <a:endParaRPr lang="en-US" sz="1200" dirty="0"/>
           </a:p>
           <a:p>
             <a:pPr marL="342900" indent="-342900">
@@ -24461,7 +24105,7 @@
               <a:buChar char="•"/>
             </a:pPr>
             <a:r>
-              <a:rPr lang="en-US" sz="1400" dirty="0">
+              <a:rPr lang="en-US" sz="1200" dirty="0">
                 <a:solidFill>
                   <a:srgbClr val="636E72"/>
                 </a:solidFill>
@@ -24469,9 +24113,9 @@
                 <a:ea typeface="Calibri" pitchFamily="34" charset="-122"/>
                 <a:cs typeface="Calibri" pitchFamily="34" charset="-120"/>
               </a:rPr>
-              <a:t>文件里每个浮点数 = 声波振到什么位置</a:t>
-            </a:r>
-            <a:endParaRPr lang="en-US" sz="1400" dirty="0"/>
+              <a:t>每个浮点数 = 声波振到什么位置</a:t>
+            </a:r>
+            <a:endParaRPr lang="en-US" sz="1200" dirty="0"/>
           </a:p>
           <a:p>
             <a:pPr marL="342900" indent="-342900">
@@ -24479,7 +24123,7 @@
               <a:buChar char="•"/>
             </a:pPr>
             <a:r>
-              <a:rPr lang="en-US" sz="1400" dirty="0">
+              <a:rPr lang="en-US" sz="1200" dirty="0">
                 <a:solidFill>
                   <a:srgbClr val="636E72"/>
                 </a:solidFill>
@@ -24487,9 +24131,9 @@
                 <a:ea typeface="Calibri" pitchFamily="34" charset="-122"/>
                 <a:cs typeface="Calibri" pitchFamily="34" charset="-120"/>
               </a:rPr>
-              <a:t>正数 → 振膜向外推，负数 → 向里拉</a:t>
-            </a:r>
-            <a:endParaRPr lang="en-US" sz="1400" dirty="0"/>
+              <a:t>每秒 16000 个点连续播放</a:t>
+            </a:r>
+            <a:endParaRPr lang="en-US" sz="1200" dirty="0"/>
           </a:p>
           <a:p>
             <a:pPr marL="342900" indent="-342900">
@@ -24497,47 +24141,88 @@
               <a:buChar char="•"/>
             </a:pPr>
             <a:r>
-              <a:rPr lang="en-US" sz="1400" dirty="0">
-                <a:solidFill>
-                  <a:srgbClr val="636E72"/>
+              <a:rPr lang="en-US" sz="1200" i="1" dirty="0">
+                <a:solidFill>
+                  <a:srgbClr val="EF4444"/>
                 </a:solidFill>
                 <a:latin typeface="Calibri" pitchFamily="34" charset="0"/>
                 <a:ea typeface="Calibri" pitchFamily="34" charset="-122"/>
                 <a:cs typeface="Calibri" pitchFamily="34" charset="-120"/>
               </a:rPr>
-              <a:t>每秒 16000 个点 = 16kHz 采样率</a:t>
-            </a:r>
-            <a:endParaRPr lang="en-US" sz="1400" dirty="0"/>
-          </a:p>
-          <a:p>
-            <a:pPr marL="342900" indent="-342900">
-              <a:buSzPct val="100000"/>
-              <a:buChar char="•"/>
-            </a:pPr>
-            <a:r>
-              <a:rPr lang="en-US" sz="1400" i="1" dirty="0">
-                <a:solidFill>
-                  <a:srgbClr val="EF4444"/>
+              <a:t>看不出「男声还是女声，是 /a/ 还是 /i/」</a:t>
+            </a:r>
+            <a:endParaRPr lang="en-US" sz="1200" dirty="0"/>
+          </a:p>
+        </p:txBody>
+      </p:sp>
+      <p:sp>
+        <p:nvSpPr>
+          <p:cNvPr id="24" name="Shape 22"/>
+          <p:cNvSpPr/>
+          <p:nvPr/>
+        </p:nvSpPr>
+        <p:spPr>
+          <a:xfrm>
+            <a:off x="731520" y="3108960"/>
+            <a:ext cx="3383280" cy="1371600"/>
+          </a:xfrm>
+          <a:prstGeom prst="rect">
+            <a:avLst/>
+          </a:prstGeom>
+          <a:solidFill>
+            <a:srgbClr val="F0F2F4"/>
+          </a:solidFill>
+          <a:ln/>
+        </p:spPr>
+      </p:sp>
+      <p:sp>
+        <p:nvSpPr>
+          <p:cNvPr id="25" name="Text 23"/>
+          <p:cNvSpPr/>
+          <p:nvPr/>
+        </p:nvSpPr>
+        <p:spPr>
+          <a:xfrm>
+            <a:off x="731520" y="3108960"/>
+            <a:ext cx="3383280" cy="1371600"/>
+          </a:xfrm>
+          <a:prstGeom prst="rect">
+            <a:avLst/>
+          </a:prstGeom>
+          <a:noFill/>
+          <a:ln/>
+        </p:spPr>
+        <p:txBody>
+          <a:bodyPr wrap="square" lIns="0" tIns="0" rIns="0" bIns="0" rtlCol="0" anchor="ctr"/>
+          <a:lstStyle/>
+          <a:p>
+            <a:pPr algn="ctr" indent="0" marL="0">
+              <a:buNone/>
+            </a:pPr>
+            <a:r>
+              <a:rPr lang="en-US" sz="1100" dirty="0">
+                <a:solidFill>
+                  <a:srgbClr val="9CA3A8"/>
                 </a:solidFill>
                 <a:latin typeface="Calibri" pitchFamily="34" charset="0"/>
                 <a:ea typeface="Calibri" pitchFamily="34" charset="-122"/>
                 <a:cs typeface="Calibri" pitchFamily="34" charset="-120"/>
               </a:rPr>
-              <a:t>看不出「男声还是女声，是 /a/ 还是 /i/」</a:t>
-            </a:r>
-            <a:endParaRPr lang="en-US" sz="1400" dirty="0"/>
-          </a:p>
-        </p:txBody>
-      </p:sp>
-      <p:sp>
-        <p:nvSpPr>
-          <p:cNvPr id="24" name="Text 22"/>
-          <p:cNvSpPr/>
-          <p:nvPr/>
-        </p:nvSpPr>
-        <p:spPr>
-          <a:xfrm>
-            <a:off x="4114800" y="2560320"/>
+              <a:t>(waveform)</a:t>
+            </a:r>
+            <a:endParaRPr lang="en-US" sz="1100" dirty="0"/>
+          </a:p>
+        </p:txBody>
+      </p:sp>
+      <p:sp>
+        <p:nvSpPr>
+          <p:cNvPr id="26" name="Text 24"/>
+          <p:cNvSpPr/>
+          <p:nvPr/>
+        </p:nvSpPr>
+        <p:spPr>
+          <a:xfrm>
+            <a:off x="4114800" y="2834640"/>
             <a:ext cx="731520" cy="457200"/>
           </a:xfrm>
           <a:prstGeom prst="rect">
@@ -24570,14 +24255,14 @@
       </p:sp>
       <p:sp>
         <p:nvSpPr>
-          <p:cNvPr id="25" name="Shape 23"/>
+          <p:cNvPr id="27" name="Shape 25"/>
           <p:cNvSpPr/>
           <p:nvPr/>
         </p:nvSpPr>
         <p:spPr>
           <a:xfrm>
             <a:off x="4754880" y="1463040"/>
-            <a:ext cx="3931920" cy="2926080"/>
+            <a:ext cx="3931920" cy="3200400"/>
           </a:xfrm>
           <a:prstGeom prst="rect">
             <a:avLst/>
@@ -24597,14 +24282,14 @@
       </p:sp>
       <p:sp>
         <p:nvSpPr>
-          <p:cNvPr id="26" name="Shape 24"/>
+          <p:cNvPr id="28" name="Shape 26"/>
           <p:cNvSpPr/>
           <p:nvPr/>
         </p:nvSpPr>
         <p:spPr>
           <a:xfrm>
             <a:off x="4754880" y="1463040"/>
-            <a:ext cx="54864" cy="2926080"/>
+            <a:ext cx="54864" cy="3200400"/>
           </a:xfrm>
           <a:prstGeom prst="rect">
             <a:avLst/>
@@ -24617,14 +24302,14 @@
       </p:sp>
       <p:sp>
         <p:nvSpPr>
-          <p:cNvPr id="27" name="Text 25"/>
+          <p:cNvPr id="29" name="Text 27"/>
           <p:cNvSpPr/>
           <p:nvPr/>
         </p:nvSpPr>
         <p:spPr>
           <a:xfrm>
             <a:off x="5029200" y="1600200"/>
-            <a:ext cx="3474720" cy="411480"/>
+            <a:ext cx="3474720" cy="320040"/>
           </a:xfrm>
           <a:prstGeom prst="rect">
             <a:avLst/>
@@ -24640,7 +24325,7 @@
               <a:buNone/>
             </a:pPr>
             <a:r>
-              <a:rPr lang="en-US" sz="1800" b="1" dirty="0">
+              <a:rPr lang="en-US" sz="1600" b="1" dirty="0">
                 <a:solidFill>
                   <a:srgbClr val="2D3436"/>
                 </a:solidFill>
@@ -24650,20 +24335,20 @@
               </a:rPr>
               <a:t>频谱 Spectrogram</a:t>
             </a:r>
-            <a:endParaRPr lang="en-US" sz="1800" dirty="0"/>
-          </a:p>
-        </p:txBody>
-      </p:sp>
-      <p:sp>
-        <p:nvSpPr>
-          <p:cNvPr id="28" name="Text 26"/>
-          <p:cNvSpPr/>
-          <p:nvPr/>
-        </p:nvSpPr>
-        <p:spPr>
-          <a:xfrm>
-            <a:off x="5029200" y="2103120"/>
-            <a:ext cx="3474720" cy="2103120"/>
+            <a:endParaRPr lang="en-US" sz="1600" dirty="0"/>
+          </a:p>
+        </p:txBody>
+      </p:sp>
+      <p:sp>
+        <p:nvSpPr>
+          <p:cNvPr id="30" name="Text 28"/>
+          <p:cNvSpPr/>
+          <p:nvPr/>
+        </p:nvSpPr>
+        <p:spPr>
+          <a:xfrm>
+            <a:off x="5029200" y="1965960"/>
+            <a:ext cx="3474720" cy="1005840"/>
           </a:xfrm>
           <a:prstGeom prst="rect">
             <a:avLst/>
@@ -24680,7 +24365,7 @@
               <a:buChar char="•"/>
             </a:pPr>
             <a:r>
-              <a:rPr lang="en-US" sz="1400" dirty="0">
+              <a:rPr lang="en-US" sz="1200" dirty="0">
                 <a:solidFill>
                   <a:srgbClr val="636E72"/>
                 </a:solidFill>
@@ -24690,7 +24375,7 @@
               </a:rPr>
               <a:t>横轴 = 时间，纵轴 = 频率，颜色 = 能量</a:t>
             </a:r>
-            <a:endParaRPr lang="en-US" sz="1400" dirty="0"/>
+            <a:endParaRPr lang="en-US" sz="1200" dirty="0"/>
           </a:p>
           <a:p>
             <a:pPr marL="342900" indent="-342900">
@@ -24698,7 +24383,7 @@
               <a:buChar char="•"/>
             </a:pPr>
             <a:r>
-              <a:rPr lang="en-US" sz="1400" dirty="0">
+              <a:rPr lang="en-US" sz="1200" dirty="0">
                 <a:solidFill>
                   <a:srgbClr val="636E72"/>
                 </a:solidFill>
@@ -24708,7 +24393,7 @@
               </a:rPr>
               <a:t>能量集中在低频 → 男声</a:t>
             </a:r>
-            <a:endParaRPr lang="en-US" sz="1400" dirty="0"/>
+            <a:endParaRPr lang="en-US" sz="1200" dirty="0"/>
           </a:p>
           <a:p>
             <a:pPr marL="342900" indent="-342900">
@@ -24716,7 +24401,7 @@
               <a:buChar char="•"/>
             </a:pPr>
             <a:r>
-              <a:rPr lang="en-US" sz="1400" dirty="0">
+              <a:rPr lang="en-US" sz="1200" dirty="0">
                 <a:solidFill>
                   <a:srgbClr val="636E72"/>
                 </a:solidFill>
@@ -24726,7 +24411,7 @@
               </a:rPr>
               <a:t>高频横杠 → 摩擦音 /s/</a:t>
             </a:r>
-            <a:endParaRPr lang="en-US" sz="1400" dirty="0"/>
+            <a:endParaRPr lang="en-US" sz="1200" dirty="0"/>
           </a:p>
           <a:p>
             <a:pPr marL="342900" indent="-342900">
@@ -24734,35 +24419,76 @@
               <a:buChar char="•"/>
             </a:pPr>
             <a:r>
-              <a:rPr lang="en-US" sz="1400" dirty="0">
-                <a:solidFill>
-                  <a:srgbClr val="636E72"/>
+              <a:rPr lang="en-US" sz="1200" dirty="0">
+                <a:solidFill>
+                  <a:srgbClr val="10B981"/>
                 </a:solidFill>
                 <a:latin typeface="Calibri" pitchFamily="34" charset="0"/>
                 <a:ea typeface="Calibri" pitchFamily="34" charset="-122"/>
                 <a:cs typeface="Calibri" pitchFamily="34" charset="-120"/>
               </a:rPr>
-              <a:t>一眼看出音色、音高、内容</a:t>
-            </a:r>
-            <a:endParaRPr lang="en-US" sz="1400" dirty="0"/>
-          </a:p>
-          <a:p>
-            <a:pPr marL="342900" indent="-342900">
-              <a:buSzPct val="100000"/>
-              <a:buChar char="•"/>
-            </a:pPr>
-            <a:r>
-              <a:rPr lang="en-US" sz="1400" dirty="0">
-                <a:solidFill>
-                  <a:srgbClr val="10B981"/>
+              <a:t>语音的本质 = 频率能量随时间变化</a:t>
+            </a:r>
+            <a:endParaRPr lang="en-US" sz="1200" dirty="0"/>
+          </a:p>
+        </p:txBody>
+      </p:sp>
+      <p:sp>
+        <p:nvSpPr>
+          <p:cNvPr id="31" name="Shape 29"/>
+          <p:cNvSpPr/>
+          <p:nvPr/>
+        </p:nvSpPr>
+        <p:spPr>
+          <a:xfrm>
+            <a:off x="5029200" y="3108960"/>
+            <a:ext cx="3383280" cy="1371600"/>
+          </a:xfrm>
+          <a:prstGeom prst="rect">
+            <a:avLst/>
+          </a:prstGeom>
+          <a:solidFill>
+            <a:srgbClr val="F0F2F4"/>
+          </a:solidFill>
+          <a:ln/>
+        </p:spPr>
+      </p:sp>
+      <p:sp>
+        <p:nvSpPr>
+          <p:cNvPr id="32" name="Text 30"/>
+          <p:cNvSpPr/>
+          <p:nvPr/>
+        </p:nvSpPr>
+        <p:spPr>
+          <a:xfrm>
+            <a:off x="5029200" y="3108960"/>
+            <a:ext cx="3383280" cy="1371600"/>
+          </a:xfrm>
+          <a:prstGeom prst="rect">
+            <a:avLst/>
+          </a:prstGeom>
+          <a:noFill/>
+          <a:ln/>
+        </p:spPr>
+        <p:txBody>
+          <a:bodyPr wrap="square" lIns="0" tIns="0" rIns="0" bIns="0" rtlCol="0" anchor="ctr"/>
+          <a:lstStyle/>
+          <a:p>
+            <a:pPr algn="ctr" indent="0" marL="0">
+              <a:buNone/>
+            </a:pPr>
+            <a:r>
+              <a:rPr lang="en-US" sz="1100" dirty="0">
+                <a:solidFill>
+                  <a:srgbClr val="9CA3A8"/>
                 </a:solidFill>
                 <a:latin typeface="Calibri" pitchFamily="34" charset="0"/>
                 <a:ea typeface="Calibri" pitchFamily="34" charset="-122"/>
                 <a:cs typeface="Calibri" pitchFamily="34" charset="-120"/>
               </a:rPr>
-              <a:t>✓ 语音的本质 = 不同频率的能量随时间变化</a:t>
-            </a:r>
-            <a:endParaRPr lang="en-US" sz="1400" dirty="0"/>
+              <a:t>(spectrogram)</a:t>
+            </a:r>
+            <a:endParaRPr lang="en-US" sz="1100" dirty="0"/>
           </a:p>
         </p:txBody>
       </p:sp>

</xml_diff>